<commit_message>
PPT includes Evaluation now
</commit_message>
<xml_diff>
--- a/PPT/Extending Kubernetes Self-Healing for Networking Failure.pptx
+++ b/PPT/Extending Kubernetes Self-Healing for Networking Failure.pptx
@@ -5,10 +5,10 @@
     <p:sldMasterId id="2147483825" r:id="rId4"/>
   </p:sldMasterIdLst>
   <p:notesMasterIdLst>
-    <p:notesMasterId r:id="rId18"/>
+    <p:notesMasterId r:id="rId19"/>
   </p:notesMasterIdLst>
   <p:handoutMasterIdLst>
-    <p:handoutMasterId r:id="rId19"/>
+    <p:handoutMasterId r:id="rId20"/>
   </p:handoutMasterIdLst>
   <p:sldIdLst>
     <p:sldId id="256" r:id="rId5"/>
@@ -23,7 +23,8 @@
     <p:sldId id="266" r:id="rId14"/>
     <p:sldId id="264" r:id="rId15"/>
     <p:sldId id="268" r:id="rId16"/>
-    <p:sldId id="269" r:id="rId17"/>
+    <p:sldId id="271" r:id="rId17"/>
+    <p:sldId id="269" r:id="rId18"/>
   </p:sldIdLst>
   <p:sldSz cx="12192000" cy="6858000"/>
   <p:notesSz cx="6858000" cy="9144000"/>
@@ -236,7 +237,7 @@
           <a:p>
             <a:fld id="{D5D1EC30-5B0B-48D0-A1A8-66A96720DF24}" type="datetimeFigureOut">
               <a:rPr lang="en-US" smtClean="0"/>
-              <a:t>9/4/2026</a:t>
+              <a:t>9/4/26</a:t>
             </a:fld>
             <a:endParaRPr lang="en-US" dirty="0"/>
           </a:p>
@@ -413,7 +414,7 @@
           <a:p>
             <a:fld id="{69F68A4D-42A7-45F7-9930-00E8DCB48D7E}" type="datetimeFigureOut">
               <a:rPr lang="en-US" smtClean="0"/>
-              <a:t>9/4/2026</a:t>
+              <a:t>9/4/26</a:t>
             </a:fld>
             <a:endParaRPr lang="en-US" dirty="0"/>
           </a:p>
@@ -908,6 +909,174 @@
 </p:notes>
 </file>
 
+<file path=ppt/notesSlides/notesSlide2.xml><?xml version="1.0" encoding="utf-8"?>
+<p:notes xmlns:a="http://schemas.openxmlformats.org/drawingml/2006/main" xmlns:r="http://schemas.openxmlformats.org/officeDocument/2006/relationships" xmlns:p="http://schemas.openxmlformats.org/presentationml/2006/main">
+  <p:cSld>
+    <p:spTree>
+      <p:nvGrpSpPr>
+        <p:cNvPr id="1" name=""/>
+        <p:cNvGrpSpPr/>
+        <p:nvPr/>
+      </p:nvGrpSpPr>
+      <p:grpSpPr>
+        <a:xfrm>
+          <a:off x="0" y="0"/>
+          <a:ext cx="0" cy="0"/>
+          <a:chOff x="0" y="0"/>
+          <a:chExt cx="0" cy="0"/>
+        </a:xfrm>
+      </p:grpSpPr>
+      <p:sp>
+        <p:nvSpPr>
+          <p:cNvPr id="2" name="Slide Image Placeholder 1"/>
+          <p:cNvSpPr>
+            <a:spLocks noGrp="1" noRot="1" noChangeAspect="1"/>
+          </p:cNvSpPr>
+          <p:nvPr>
+            <p:ph type="sldImg"/>
+          </p:nvPr>
+        </p:nvSpPr>
+        <p:spPr/>
+      </p:sp>
+      <p:sp>
+        <p:nvSpPr>
+          <p:cNvPr id="3" name="Notes Placeholder 2"/>
+          <p:cNvSpPr>
+            <a:spLocks noGrp="1"/>
+          </p:cNvSpPr>
+          <p:nvPr>
+            <p:ph type="body" idx="1"/>
+          </p:nvPr>
+        </p:nvSpPr>
+        <p:spPr/>
+        <p:txBody>
+          <a:bodyPr/>
+          <a:lstStyle/>
+          <a:p>
+            <a:endParaRPr lang="en-US" dirty="0"/>
+          </a:p>
+        </p:txBody>
+      </p:sp>
+      <p:sp>
+        <p:nvSpPr>
+          <p:cNvPr id="4" name="Slide Number Placeholder 3"/>
+          <p:cNvSpPr>
+            <a:spLocks noGrp="1"/>
+          </p:cNvSpPr>
+          <p:nvPr>
+            <p:ph type="sldNum" sz="quarter" idx="5"/>
+          </p:nvPr>
+        </p:nvSpPr>
+        <p:spPr/>
+        <p:txBody>
+          <a:bodyPr/>
+          <a:lstStyle/>
+          <a:p>
+            <a:fld id="{BFDD6F49-EBB7-4CCF-97A8-E526BB28BB69}" type="slidenum">
+              <a:rPr lang="en-US" smtClean="0"/>
+              <a:t>12</a:t>
+            </a:fld>
+            <a:endParaRPr lang="en-US" dirty="0"/>
+          </a:p>
+        </p:txBody>
+      </p:sp>
+    </p:spTree>
+    <p:extLst>
+      <p:ext uri="{BB962C8B-B14F-4D97-AF65-F5344CB8AC3E}">
+        <p14:creationId xmlns:p14="http://schemas.microsoft.com/office/powerpoint/2010/main" val="2188220576"/>
+      </p:ext>
+    </p:extLst>
+  </p:cSld>
+  <p:clrMapOvr>
+    <a:masterClrMapping/>
+  </p:clrMapOvr>
+</p:notes>
+</file>
+
+<file path=ppt/notesSlides/notesSlide3.xml><?xml version="1.0" encoding="utf-8"?>
+<p:notes xmlns:a="http://schemas.openxmlformats.org/drawingml/2006/main" xmlns:r="http://schemas.openxmlformats.org/officeDocument/2006/relationships" xmlns:p="http://schemas.openxmlformats.org/presentationml/2006/main">
+  <p:cSld>
+    <p:spTree>
+      <p:nvGrpSpPr>
+        <p:cNvPr id="1" name=""/>
+        <p:cNvGrpSpPr/>
+        <p:nvPr/>
+      </p:nvGrpSpPr>
+      <p:grpSpPr>
+        <a:xfrm>
+          <a:off x="0" y="0"/>
+          <a:ext cx="0" cy="0"/>
+          <a:chOff x="0" y="0"/>
+          <a:chExt cx="0" cy="0"/>
+        </a:xfrm>
+      </p:grpSpPr>
+      <p:sp>
+        <p:nvSpPr>
+          <p:cNvPr id="2" name="Slide Image Placeholder 1"/>
+          <p:cNvSpPr>
+            <a:spLocks noGrp="1" noRot="1" noChangeAspect="1"/>
+          </p:cNvSpPr>
+          <p:nvPr>
+            <p:ph type="sldImg"/>
+          </p:nvPr>
+        </p:nvSpPr>
+        <p:spPr/>
+      </p:sp>
+      <p:sp>
+        <p:nvSpPr>
+          <p:cNvPr id="3" name="Notes Placeholder 2"/>
+          <p:cNvSpPr>
+            <a:spLocks noGrp="1"/>
+          </p:cNvSpPr>
+          <p:nvPr>
+            <p:ph type="body" idx="1"/>
+          </p:nvPr>
+        </p:nvSpPr>
+        <p:spPr/>
+        <p:txBody>
+          <a:bodyPr/>
+          <a:lstStyle/>
+          <a:p>
+            <a:endParaRPr lang="en-US" dirty="0"/>
+          </a:p>
+        </p:txBody>
+      </p:sp>
+      <p:sp>
+        <p:nvSpPr>
+          <p:cNvPr id="4" name="Slide Number Placeholder 3"/>
+          <p:cNvSpPr>
+            <a:spLocks noGrp="1"/>
+          </p:cNvSpPr>
+          <p:nvPr>
+            <p:ph type="sldNum" sz="quarter" idx="5"/>
+          </p:nvPr>
+        </p:nvSpPr>
+        <p:spPr/>
+        <p:txBody>
+          <a:bodyPr/>
+          <a:lstStyle/>
+          <a:p>
+            <a:fld id="{BFDD6F49-EBB7-4CCF-97A8-E526BB28BB69}" type="slidenum">
+              <a:rPr lang="en-US" smtClean="0"/>
+              <a:t>14</a:t>
+            </a:fld>
+            <a:endParaRPr lang="en-US" dirty="0"/>
+          </a:p>
+        </p:txBody>
+      </p:sp>
+    </p:spTree>
+    <p:extLst>
+      <p:ext uri="{BB962C8B-B14F-4D97-AF65-F5344CB8AC3E}">
+        <p14:creationId xmlns:p14="http://schemas.microsoft.com/office/powerpoint/2010/main" val="428442681"/>
+      </p:ext>
+    </p:extLst>
+  </p:cSld>
+  <p:clrMapOvr>
+    <a:masterClrMapping/>
+  </p:clrMapOvr>
+</p:notes>
+</file>
+
 <file path=ppt/slideLayouts/slideLayout1.xml><?xml version="1.0" encoding="utf-8"?>
 <p:sldLayout xmlns:a="http://schemas.openxmlformats.org/drawingml/2006/main" xmlns:r="http://schemas.openxmlformats.org/officeDocument/2006/relationships" xmlns:p="http://schemas.openxmlformats.org/presentationml/2006/main" preserve="1" userDrawn="1">
   <p:cSld name="Title with Picture">
@@ -1189,7 +1358,7 @@
             <a:fld id="{CA325475-EA0F-49B2-A586-CC0D8CB91667}" type="datetime1">
               <a:rPr lang="en-US" smtClean="0"/>
               <a:pPr/>
-              <a:t>9/4/2026</a:t>
+              <a:t>9/4/26</a:t>
             </a:fld>
             <a:endParaRPr lang="en-US" dirty="0"/>
           </a:p>
@@ -1454,7 +1623,7 @@
           <a:p>
             <a:fld id="{E793227F-7A38-4FCC-BBE5-462C6ABA0D7C}" type="datetime1">
               <a:rPr lang="en-US" smtClean="0"/>
-              <a:t>9/4/2026</a:t>
+              <a:t>9/4/26</a:t>
             </a:fld>
             <a:endParaRPr lang="en-US" dirty="0"/>
           </a:p>
@@ -1921,7 +2090,7 @@
             <a:fld id="{CA325475-EA0F-49B2-A586-CC0D8CB91667}" type="datetime1">
               <a:rPr lang="en-US" smtClean="0"/>
               <a:pPr/>
-              <a:t>9/4/2026</a:t>
+              <a:t>9/4/26</a:t>
             </a:fld>
             <a:endParaRPr lang="en-US" dirty="0"/>
           </a:p>
@@ -2163,7 +2332,7 @@
           <a:p>
             <a:fld id="{1107640D-701E-4505-B3CF-EF9407231E3A}" type="datetime1">
               <a:rPr lang="en-US" smtClean="0"/>
-              <a:t>9/4/2026</a:t>
+              <a:t>9/4/26</a:t>
             </a:fld>
             <a:endParaRPr lang="en-US" dirty="0"/>
           </a:p>
@@ -2434,7 +2603,7 @@
           <a:p>
             <a:fld id="{BA858915-0BD2-4619-96F8-2000A958401A}" type="datetime1">
               <a:rPr lang="en-US" smtClean="0"/>
-              <a:t>9/4/2026</a:t>
+              <a:t>9/4/26</a:t>
             </a:fld>
             <a:endParaRPr lang="en-US" dirty="0"/>
           </a:p>
@@ -2721,7 +2890,7 @@
           <a:p>
             <a:fld id="{78D97C48-2090-4C6A-8BA6-AD652515C489}" type="datetime1">
               <a:rPr lang="en-US" smtClean="0"/>
-              <a:t>9/4/2026</a:t>
+              <a:t>9/4/26</a:t>
             </a:fld>
             <a:endParaRPr lang="en-US" dirty="0"/>
           </a:p>
@@ -3008,7 +3177,7 @@
           <a:p>
             <a:fld id="{A66C18EB-E5A2-46FD-AE56-36A2660D9755}" type="datetime1">
               <a:rPr lang="en-US" smtClean="0"/>
-              <a:t>9/4/2026</a:t>
+              <a:t>9/4/26</a:t>
             </a:fld>
             <a:endParaRPr lang="en-US" dirty="0"/>
           </a:p>
@@ -3295,7 +3464,7 @@
           <a:p>
             <a:fld id="{DE71F173-72DA-43D0-80E2-6EBC494B1FEF}" type="datetime1">
               <a:rPr lang="en-US" smtClean="0"/>
-              <a:t>9/4/2026</a:t>
+              <a:t>9/4/26</a:t>
             </a:fld>
             <a:endParaRPr lang="en-US" dirty="0"/>
           </a:p>
@@ -3635,7 +3804,7 @@
             <a:fld id="{CA325475-EA0F-49B2-A586-CC0D8CB91667}" type="datetime1">
               <a:rPr lang="en-US" smtClean="0"/>
               <a:pPr/>
-              <a:t>9/4/2026</a:t>
+              <a:t>9/4/26</a:t>
             </a:fld>
             <a:endParaRPr lang="en-US" dirty="0"/>
           </a:p>
@@ -4016,7 +4185,7 @@
             <a:fld id="{CA325475-EA0F-49B2-A586-CC0D8CB91667}" type="datetime1">
               <a:rPr lang="en-US" smtClean="0"/>
               <a:pPr/>
-              <a:t>9/4/2026</a:t>
+              <a:t>9/4/26</a:t>
             </a:fld>
             <a:endParaRPr lang="en-US" dirty="0"/>
           </a:p>
@@ -4397,7 +4566,7 @@
             <a:fld id="{CA325475-EA0F-49B2-A586-CC0D8CB91667}" type="datetime1">
               <a:rPr lang="en-US" smtClean="0"/>
               <a:pPr/>
-              <a:t>9/4/2026</a:t>
+              <a:t>9/4/26</a:t>
             </a:fld>
             <a:endParaRPr lang="en-US" dirty="0"/>
           </a:p>
@@ -4624,7 +4793,7 @@
           <a:p>
             <a:fld id="{D8F76615-F428-46F8-B333-52721A2A1D31}" type="datetime1">
               <a:rPr lang="en-US" smtClean="0"/>
-              <a:t>9/4/2026</a:t>
+              <a:t>9/4/26</a:t>
             </a:fld>
             <a:endParaRPr lang="en-US" dirty="0"/>
           </a:p>
@@ -4979,7 +5148,7 @@
           <a:p>
             <a:fld id="{33D736FE-15B3-4F20-9261-F868C8825F0F}" type="datetime1">
               <a:rPr lang="en-US" smtClean="0"/>
-              <a:t>9/4/2026</a:t>
+              <a:t>9/4/26</a:t>
             </a:fld>
             <a:endParaRPr lang="en-US" dirty="0"/>
           </a:p>
@@ -5476,7 +5645,7 @@
             <a:fld id="{CA325475-EA0F-49B2-A586-CC0D8CB91667}" type="datetime1">
               <a:rPr lang="en-US" smtClean="0"/>
               <a:pPr/>
-              <a:t>9/4/2026</a:t>
+              <a:t>9/4/26</a:t>
             </a:fld>
             <a:endParaRPr lang="en-US" dirty="0"/>
           </a:p>
@@ -5855,7 +6024,7 @@
             <a:fld id="{CA325475-EA0F-49B2-A586-CC0D8CB91667}" type="datetime1">
               <a:rPr lang="en-US" smtClean="0"/>
               <a:pPr/>
-              <a:t>9/4/2026</a:t>
+              <a:t>9/4/26</a:t>
             </a:fld>
             <a:endParaRPr lang="en-US" dirty="0"/>
           </a:p>
@@ -6235,7 +6404,7 @@
             <a:fld id="{CA325475-EA0F-49B2-A586-CC0D8CB91667}" type="datetime1">
               <a:rPr lang="en-US" smtClean="0"/>
               <a:pPr/>
-              <a:t>9/4/2026</a:t>
+              <a:t>9/4/26</a:t>
             </a:fld>
             <a:endParaRPr lang="en-US" dirty="0"/>
           </a:p>
@@ -6610,7 +6779,7 @@
             <a:fld id="{CA325475-EA0F-49B2-A586-CC0D8CB91667}" type="datetime1">
               <a:rPr lang="en-US" smtClean="0"/>
               <a:pPr/>
-              <a:t>9/4/2026</a:t>
+              <a:t>9/4/26</a:t>
             </a:fld>
             <a:endParaRPr lang="en-US" dirty="0"/>
           </a:p>
@@ -6915,7 +7084,7 @@
           <a:p>
             <a:fld id="{33D736FE-15B3-4F20-9261-F868C8825F0F}" type="datetime1">
               <a:rPr lang="en-US" smtClean="0"/>
-              <a:t>9/4/2026</a:t>
+              <a:t>9/4/26</a:t>
             </a:fld>
             <a:endParaRPr lang="en-US" dirty="0"/>
           </a:p>
@@ -7322,7 +7491,7 @@
           <a:p>
             <a:fld id="{33D736FE-15B3-4F20-9261-F868C8825F0F}" type="datetime1">
               <a:rPr lang="en-US" smtClean="0"/>
-              <a:t>9/4/2026</a:t>
+              <a:t>9/4/26</a:t>
             </a:fld>
             <a:endParaRPr lang="en-US" dirty="0"/>
           </a:p>
@@ -7803,7 +7972,7 @@
             <a:fld id="{CA325475-EA0F-49B2-A586-CC0D8CB91667}" type="datetime1">
               <a:rPr lang="en-US" smtClean="0"/>
               <a:pPr/>
-              <a:t>9/4/2026</a:t>
+              <a:t>9/4/26</a:t>
             </a:fld>
             <a:endParaRPr lang="en-US" dirty="0"/>
           </a:p>
@@ -8182,7 +8351,7 @@
             <a:fld id="{CA325475-EA0F-49B2-A586-CC0D8CB91667}" type="datetime1">
               <a:rPr lang="en-US" smtClean="0"/>
               <a:pPr/>
-              <a:t>9/4/2026</a:t>
+              <a:t>9/4/26</a:t>
             </a:fld>
             <a:endParaRPr lang="en-US" dirty="0"/>
           </a:p>
@@ -8449,7 +8618,7 @@
           <a:p>
             <a:fld id="{E1E31391-F4B8-4A23-8935-365F41031646}" type="datetime1">
               <a:rPr lang="en-US" smtClean="0"/>
-              <a:t>9/4/2026</a:t>
+              <a:t>9/4/26</a:t>
             </a:fld>
             <a:endParaRPr lang="en-US" dirty="0"/>
           </a:p>
@@ -8972,7 +9141,7 @@
             <a:fld id="{CA325475-EA0F-49B2-A586-CC0D8CB91667}" type="datetime1">
               <a:rPr lang="en-US" smtClean="0"/>
               <a:pPr/>
-              <a:t>9/4/2026</a:t>
+              <a:t>9/4/26</a:t>
             </a:fld>
             <a:endParaRPr lang="en-US" dirty="0"/>
           </a:p>
@@ -9314,7 +9483,7 @@
             <a:fld id="{CA325475-EA0F-49B2-A586-CC0D8CB91667}" type="datetime1">
               <a:rPr lang="en-US" smtClean="0"/>
               <a:pPr/>
-              <a:t>9/4/2026</a:t>
+              <a:t>9/4/26</a:t>
             </a:fld>
             <a:endParaRPr lang="en-US" dirty="0"/>
           </a:p>
@@ -9681,7 +9850,7 @@
           <a:p>
             <a:fld id="{E1E31391-F4B8-4A23-8935-365F41031646}" type="datetime1">
               <a:rPr lang="en-US" smtClean="0"/>
-              <a:t>9/4/2026</a:t>
+              <a:t>9/4/26</a:t>
             </a:fld>
             <a:endParaRPr lang="en-US" dirty="0"/>
           </a:p>
@@ -10214,7 +10383,7 @@
             <a:fld id="{CA325475-EA0F-49B2-A586-CC0D8CB91667}" type="datetime1">
               <a:rPr lang="en-US" smtClean="0"/>
               <a:pPr/>
-              <a:t>9/4/2026</a:t>
+              <a:t>9/4/26</a:t>
             </a:fld>
             <a:endParaRPr lang="en-US" dirty="0"/>
           </a:p>
@@ -10593,7 +10762,7 @@
             <a:fld id="{CA325475-EA0F-49B2-A586-CC0D8CB91667}" type="datetime1">
               <a:rPr lang="en-US" smtClean="0"/>
               <a:pPr/>
-              <a:t>9/4/2026</a:t>
+              <a:t>9/4/26</a:t>
             </a:fld>
             <a:endParaRPr lang="en-US" dirty="0"/>
           </a:p>
@@ -10865,7 +11034,7 @@
           <a:p>
             <a:fld id="{8EE8507B-3789-49BC-A5B5-D3B2B10E5F24}" type="datetime1">
               <a:rPr lang="en-US" smtClean="0"/>
-              <a:t>9/4/2026</a:t>
+              <a:t>9/4/26</a:t>
             </a:fld>
             <a:endParaRPr lang="en-US" dirty="0"/>
           </a:p>
@@ -11288,7 +11457,7 @@
           <a:p>
             <a:fld id="{8EE8507B-3789-49BC-A5B5-D3B2B10E5F24}" type="datetime1">
               <a:rPr lang="en-US" smtClean="0"/>
-              <a:t>9/4/2026</a:t>
+              <a:t>9/4/26</a:t>
             </a:fld>
             <a:endParaRPr lang="en-US" dirty="0"/>
           </a:p>
@@ -11711,7 +11880,7 @@
           <a:p>
             <a:fld id="{8EE8507B-3789-49BC-A5B5-D3B2B10E5F24}" type="datetime1">
               <a:rPr lang="en-US" smtClean="0"/>
-              <a:t>9/4/2026</a:t>
+              <a:t>9/4/26</a:t>
             </a:fld>
             <a:endParaRPr lang="en-US" dirty="0"/>
           </a:p>
@@ -12073,7 +12242,7 @@
           <a:p>
             <a:fld id="{D6F51461-EBBE-4007-A7FA-8D550B1815C8}" type="datetime1">
               <a:rPr lang="en-US" smtClean="0"/>
-              <a:t>9/4/2026</a:t>
+              <a:t>9/4/26</a:t>
             </a:fld>
             <a:endParaRPr lang="en-US" dirty="0"/>
           </a:p>
@@ -12346,7 +12515,7 @@
           <a:p>
             <a:fld id="{B57145D9-E600-48F3-8D60-FBB32619D4B7}" type="datetime1">
               <a:rPr lang="en-US" smtClean="0"/>
-              <a:t>9/4/2026</a:t>
+              <a:t>9/4/26</a:t>
             </a:fld>
             <a:endParaRPr lang="en-US" dirty="0"/>
           </a:p>
@@ -12619,7 +12788,7 @@
           <a:p>
             <a:fld id="{6988DA9F-3449-4571-B576-325E0AB8D353}" type="datetime1">
               <a:rPr lang="en-US" smtClean="0"/>
-              <a:t>9/4/2026</a:t>
+              <a:t>9/4/26</a:t>
             </a:fld>
             <a:endParaRPr lang="en-US" dirty="0"/>
           </a:p>
@@ -13039,7 +13208,7 @@
             <a:fld id="{CA325475-EA0F-49B2-A586-CC0D8CB91667}" type="datetime1">
               <a:rPr lang="en-US" smtClean="0"/>
               <a:pPr/>
-              <a:t>9/4/2026</a:t>
+              <a:t>9/4/26</a:t>
             </a:fld>
             <a:endParaRPr lang="en-US" dirty="0"/>
           </a:p>
@@ -13317,7 +13486,7 @@
           <a:p>
             <a:fld id="{72AC9CA7-4D60-41A4-A4F0-FD6D94D8C852}" type="datetime1">
               <a:rPr lang="en-US" smtClean="0"/>
-              <a:t>9/4/2026</a:t>
+              <a:t>9/4/26</a:t>
             </a:fld>
             <a:endParaRPr lang="en-US" dirty="0"/>
           </a:p>
@@ -13623,7 +13792,7 @@
           <a:p>
             <a:fld id="{C1BB4E8A-F766-4B4E-BA35-31ABBD66791B}" type="datetime1">
               <a:rPr lang="en-US" smtClean="0"/>
-              <a:t>9/4/2026</a:t>
+              <a:t>9/4/26</a:t>
             </a:fld>
             <a:endParaRPr lang="en-US" dirty="0"/>
           </a:p>
@@ -13946,7 +14115,7 @@
           <a:p>
             <a:fld id="{C1BB4E8A-F766-4B4E-BA35-31ABBD66791B}" type="datetime1">
               <a:rPr lang="en-US" smtClean="0"/>
-              <a:t>9/4/2026</a:t>
+              <a:t>9/4/26</a:t>
             </a:fld>
             <a:endParaRPr lang="en-US" dirty="0"/>
           </a:p>
@@ -14213,7 +14382,7 @@
           <a:p>
             <a:fld id="{08ED2632-1039-4FCE-A210-396E8C7520B2}" type="datetime1">
               <a:rPr lang="en-US" smtClean="0"/>
-              <a:t>9/4/2026</a:t>
+              <a:t>9/4/26</a:t>
             </a:fld>
             <a:endParaRPr lang="en-US" dirty="0"/>
           </a:p>
@@ -14537,7 +14706,7 @@
           <a:p>
             <a:fld id="{C506D844-928B-4334-9530-404CD7C81364}" type="datetime1">
               <a:rPr lang="en-US" smtClean="0"/>
-              <a:t>9/4/2026</a:t>
+              <a:t>9/4/26</a:t>
             </a:fld>
             <a:endParaRPr lang="en-US" dirty="0"/>
           </a:p>
@@ -14861,7 +15030,7 @@
           <a:p>
             <a:fld id="{228E703B-AD10-45EB-9C69-399306B4449A}" type="datetime1">
               <a:rPr lang="en-US" smtClean="0"/>
-              <a:t>9/4/2026</a:t>
+              <a:t>9/4/26</a:t>
             </a:fld>
             <a:endParaRPr lang="en-US" dirty="0"/>
           </a:p>
@@ -15199,7 +15368,7 @@
           <a:p>
             <a:fld id="{0C99F73C-A859-4554-A313-766C75404450}" type="datetime1">
               <a:rPr lang="en-US" smtClean="0"/>
-              <a:t>9/4/2026</a:t>
+              <a:t>9/4/26</a:t>
             </a:fld>
             <a:endParaRPr lang="en-US" dirty="0"/>
           </a:p>
@@ -15683,7 +15852,7 @@
           <a:p>
             <a:fld id="{BF64D68B-28A2-4855-B3C1-2440696AF665}" type="datetime1">
               <a:rPr lang="en-US" smtClean="0"/>
-              <a:t>9/4/2026</a:t>
+              <a:t>9/4/26</a:t>
             </a:fld>
             <a:endParaRPr lang="en-US" dirty="0"/>
           </a:p>
@@ -15897,7 +16066,7 @@
           <a:p>
             <a:fld id="{769DAC0D-566B-40F6-B3F6-72A0E1EDF8FC}" type="datetime1">
               <a:rPr lang="en-US" smtClean="0"/>
-              <a:t>9/4/2026</a:t>
+              <a:t>9/4/26</a:t>
             </a:fld>
             <a:endParaRPr lang="en-US" dirty="0"/>
           </a:p>
@@ -16065,7 +16234,7 @@
           <a:p>
             <a:fld id="{A34F2907-BCBA-412E-9539-603ECFD8F450}" type="datetime1">
               <a:rPr lang="en-US" smtClean="0"/>
-              <a:t>9/4/2026</a:t>
+              <a:t>9/4/26</a:t>
             </a:fld>
             <a:endParaRPr lang="en-US" dirty="0"/>
           </a:p>
@@ -16470,7 +16639,7 @@
             <a:fld id="{CA325475-EA0F-49B2-A586-CC0D8CB91667}" type="datetime1">
               <a:rPr lang="en-US" smtClean="0"/>
               <a:pPr/>
-              <a:t>9/4/2026</a:t>
+              <a:t>9/4/26</a:t>
             </a:fld>
             <a:endParaRPr lang="en-US" dirty="0"/>
           </a:p>
@@ -16810,7 +16979,7 @@
           <a:p>
             <a:fld id="{5DC6EE26-0A88-4974-AF99-F8A1B22A826A}" type="datetime1">
               <a:rPr lang="en-US" smtClean="0"/>
-              <a:t>9/4/2026</a:t>
+              <a:t>9/4/26</a:t>
             </a:fld>
             <a:endParaRPr lang="en-US" dirty="0"/>
           </a:p>
@@ -17145,7 +17314,7 @@
           <a:p>
             <a:fld id="{B9CEA849-C5D8-4949-916D-70A31634CC93}" type="datetime1">
               <a:rPr lang="en-US" smtClean="0"/>
-              <a:t>9/4/2026</a:t>
+              <a:t>9/4/26</a:t>
             </a:fld>
             <a:endParaRPr lang="en-US" dirty="0"/>
           </a:p>
@@ -17497,7 +17666,7 @@
           <a:p>
             <a:fld id="{8B1E6060-C53E-4F28-8D83-0C4FB26C4A3F}" type="datetime1">
               <a:rPr lang="en-US" smtClean="0"/>
-              <a:t>9/4/2026</a:t>
+              <a:t>9/4/26</a:t>
             </a:fld>
             <a:endParaRPr lang="en-US"/>
           </a:p>
@@ -17851,7 +18020,7 @@
           <a:p>
             <a:fld id="{1D3D1E3E-5DD4-4BAD-A138-1254BF94C224}" type="datetime1">
               <a:rPr lang="en-US" smtClean="0"/>
-              <a:t>9/4/2026</a:t>
+              <a:t>9/4/26</a:t>
             </a:fld>
             <a:endParaRPr lang="en-US"/>
           </a:p>
@@ -18100,7 +18269,7 @@
           <a:p>
             <a:fld id="{7B7D9461-0F61-4002-8F2D-B7697A0E13FF}" type="datetime1">
               <a:rPr lang="en-US" smtClean="0"/>
-              <a:t>9/4/2026</a:t>
+              <a:t>9/4/26</a:t>
             </a:fld>
             <a:endParaRPr lang="en-US" dirty="0"/>
           </a:p>
@@ -18373,7 +18542,7 @@
           <a:p>
             <a:fld id="{D6CC53FF-A9D2-44F7-87E7-301150AC66D6}" type="datetime1">
               <a:rPr lang="en-US" smtClean="0"/>
-              <a:t>9/4/2026</a:t>
+              <a:t>9/4/26</a:t>
             </a:fld>
             <a:endParaRPr lang="en-US" dirty="0"/>
           </a:p>
@@ -18678,7 +18847,7 @@
           <a:p>
             <a:fld id="{508C173C-F4FB-4840-9C6C-8C62F68E21A9}" type="datetime1">
               <a:rPr lang="en-US" smtClean="0"/>
-              <a:t>9/4/2026</a:t>
+              <a:t>9/4/26</a:t>
             </a:fld>
             <a:endParaRPr lang="en-US" dirty="0"/>
           </a:p>
@@ -18922,7 +19091,7 @@
           <a:p>
             <a:fld id="{5A31BBC1-8687-45A9-B22B-F61D547A780C}" type="datetime1">
               <a:rPr lang="en-US" smtClean="0"/>
-              <a:t>9/4/2026</a:t>
+              <a:t>9/4/26</a:t>
             </a:fld>
             <a:endParaRPr lang="en-US" dirty="0"/>
           </a:p>
@@ -19222,7 +19391,7 @@
             <a:fld id="{CA325475-EA0F-49B2-A586-CC0D8CB91667}" type="datetime1">
               <a:rPr lang="en-US" smtClean="0"/>
               <a:pPr/>
-              <a:t>9/4/2026</a:t>
+              <a:t>9/4/26</a:t>
             </a:fld>
             <a:endParaRPr lang="en-US" dirty="0"/>
           </a:p>
@@ -20056,45 +20225,801 @@
           <a:p>
             <a:r>
               <a:rPr lang="en-US" dirty="0"/>
-              <a:t>Do u </a:t>
-            </a:r>
-            <a:r>
-              <a:rPr lang="en-US" dirty="0" err="1"/>
-              <a:t>wanna</a:t>
-            </a:r>
-            <a:r>
-              <a:rPr lang="en-US" dirty="0"/>
-              <a:t> add anything?</a:t>
+              <a:t>Evaluation Scenarios</a:t>
             </a:r>
             <a:endParaRPr lang="en-IN" dirty="0"/>
           </a:p>
         </p:txBody>
       </p:sp>
-      <p:sp>
-        <p:nvSpPr>
-          <p:cNvPr id="3" name="Content Placeholder 2">
-            <a:extLst>
-              <a:ext uri="{FF2B5EF4-FFF2-40B4-BE49-F238E27FC236}">
-                <a16:creationId xmlns:a16="http://schemas.microsoft.com/office/drawing/2014/main" id="{CA3D61A5-0C13-8162-0B7D-C149762554BF}"/>
-              </a:ext>
-            </a:extLst>
-          </p:cNvPr>
-          <p:cNvSpPr>
-            <a:spLocks noGrp="1"/>
-          </p:cNvSpPr>
-          <p:nvPr>
-            <p:ph sz="quarter" idx="13"/>
-          </p:nvPr>
-        </p:nvSpPr>
-        <p:spPr/>
-        <p:txBody>
-          <a:bodyPr/>
-          <a:lstStyle/>
-          <a:p>
-            <a:endParaRPr lang="en-IN"/>
-          </a:p>
-        </p:txBody>
-      </p:sp>
+      <p:graphicFrame>
+        <p:nvGraphicFramePr>
+          <p:cNvPr id="4" name="Table 3">
+            <a:extLst>
+              <a:ext uri="{FF2B5EF4-FFF2-40B4-BE49-F238E27FC236}">
+                <a16:creationId xmlns:a16="http://schemas.microsoft.com/office/drawing/2014/main" id="{6411C8D0-FAC3-1FE9-A827-2C7CC84919F7}"/>
+              </a:ext>
+            </a:extLst>
+          </p:cNvPr>
+          <p:cNvGraphicFramePr>
+            <a:graphicFrameLocks noGrp="1"/>
+          </p:cNvGraphicFramePr>
+          <p:nvPr>
+            <p:extLst>
+              <p:ext uri="{D42A27DB-BD31-4B8C-83A1-F6EECF244321}">
+                <p14:modId xmlns:p14="http://schemas.microsoft.com/office/powerpoint/2010/main" val="1633350711"/>
+              </p:ext>
+            </p:extLst>
+          </p:nvPr>
+        </p:nvGraphicFramePr>
+        <p:xfrm>
+          <a:off x="1435100" y="1255367"/>
+          <a:ext cx="9525000" cy="4856480"/>
+        </p:xfrm>
+        <a:graphic>
+          <a:graphicData uri="http://schemas.openxmlformats.org/drawingml/2006/table">
+            <a:tbl>
+              <a:tblPr firstRow="1" bandRow="1">
+                <a:tableStyleId>{5940675A-B579-460E-94D1-54222C63F5DA}</a:tableStyleId>
+              </a:tblPr>
+              <a:tblGrid>
+                <a:gridCol w="3175000">
+                  <a:extLst>
+                    <a:ext uri="{9D8B030D-6E8A-4147-A177-3AD203B41FA5}">
+                      <a16:colId xmlns:a16="http://schemas.microsoft.com/office/drawing/2014/main" val="24108119"/>
+                    </a:ext>
+                  </a:extLst>
+                </a:gridCol>
+                <a:gridCol w="3175000">
+                  <a:extLst>
+                    <a:ext uri="{9D8B030D-6E8A-4147-A177-3AD203B41FA5}">
+                      <a16:colId xmlns:a16="http://schemas.microsoft.com/office/drawing/2014/main" val="1361968133"/>
+                    </a:ext>
+                  </a:extLst>
+                </a:gridCol>
+                <a:gridCol w="3175000">
+                  <a:extLst>
+                    <a:ext uri="{9D8B030D-6E8A-4147-A177-3AD203B41FA5}">
+                      <a16:colId xmlns:a16="http://schemas.microsoft.com/office/drawing/2014/main" val="2434022957"/>
+                    </a:ext>
+                  </a:extLst>
+                </a:gridCol>
+              </a:tblGrid>
+              <a:tr h="370840">
+                <a:tc>
+                  <a:txBody>
+                    <a:bodyPr/>
+                    <a:lstStyle/>
+                    <a:p>
+                      <a:r>
+                        <a:rPr lang="en-US" sz="1500" dirty="0"/>
+                        <a:t>Scenario</a:t>
+                      </a:r>
+                    </a:p>
+                  </a:txBody>
+                  <a:tcPr/>
+                </a:tc>
+                <a:tc>
+                  <a:txBody>
+                    <a:bodyPr/>
+                    <a:lstStyle/>
+                    <a:p>
+                      <a:r>
+                        <a:rPr lang="en-US" sz="1500" dirty="0"/>
+                        <a:t>Fault</a:t>
+                      </a:r>
+                    </a:p>
+                  </a:txBody>
+                  <a:tcPr/>
+                </a:tc>
+                <a:tc>
+                  <a:txBody>
+                    <a:bodyPr/>
+                    <a:lstStyle/>
+                    <a:p>
+                      <a:r>
+                        <a:rPr lang="en-US" sz="1500" dirty="0"/>
+                        <a:t>Expected Classification</a:t>
+                      </a:r>
+                    </a:p>
+                  </a:txBody>
+                  <a:tcPr/>
+                </a:tc>
+                <a:extLst>
+                  <a:ext uri="{0D108BD9-81ED-4DB2-BD59-A6C34878D82A}">
+                    <a16:rowId xmlns:a16="http://schemas.microsoft.com/office/drawing/2014/main" val="1598255110"/>
+                  </a:ext>
+                </a:extLst>
+              </a:tr>
+              <a:tr h="370840">
+                <a:tc>
+                  <a:txBody>
+                    <a:bodyPr/>
+                    <a:lstStyle/>
+                    <a:p>
+                      <a:r>
+                        <a:rPr lang="en-US" sz="1500" dirty="0"/>
+                        <a:t>F1</a:t>
+                      </a:r>
+                    </a:p>
+                  </a:txBody>
+                  <a:tcPr/>
+                </a:tc>
+                <a:tc>
+                  <a:txBody>
+                    <a:bodyPr/>
+                    <a:lstStyle/>
+                    <a:p>
+                      <a:pPr marL="0" marR="0" lvl="0" indent="0" algn="l" defTabSz="914400" rtl="0" eaLnBrk="1" fontAlgn="auto" latinLnBrk="0" hangingPunct="1">
+                        <a:lnSpc>
+                          <a:spcPct val="100000"/>
+                        </a:lnSpc>
+                        <a:spcBef>
+                          <a:spcPts val="0"/>
+                        </a:spcBef>
+                        <a:spcAft>
+                          <a:spcPts val="0"/>
+                        </a:spcAft>
+                        <a:buClrTx/>
+                        <a:buSzTx/>
+                        <a:buFontTx/>
+                        <a:buNone/>
+                        <a:tabLst/>
+                        <a:defRPr/>
+                      </a:pPr>
+                      <a:r>
+                        <a:rPr lang="en-US" sz="1500" kern="1200" dirty="0">
+                          <a:solidFill>
+                            <a:schemeClr val="tx1"/>
+                          </a:solidFill>
+                          <a:effectLst/>
+                          <a:latin typeface="+mn-lt"/>
+                          <a:ea typeface="+mn-ea"/>
+                          <a:cs typeface="+mn-cs"/>
+                        </a:rPr>
+                        <a:t>Healthy baseline </a:t>
+                      </a:r>
+                    </a:p>
+                  </a:txBody>
+                  <a:tcPr/>
+                </a:tc>
+                <a:tc>
+                  <a:txBody>
+                    <a:bodyPr/>
+                    <a:lstStyle/>
+                    <a:p>
+                      <a:pPr marL="0" marR="0" lvl="0" indent="0" algn="l" defTabSz="914400" rtl="0" eaLnBrk="1" fontAlgn="auto" latinLnBrk="0" hangingPunct="1">
+                        <a:lnSpc>
+                          <a:spcPct val="100000"/>
+                        </a:lnSpc>
+                        <a:spcBef>
+                          <a:spcPts val="0"/>
+                        </a:spcBef>
+                        <a:spcAft>
+                          <a:spcPts val="0"/>
+                        </a:spcAft>
+                        <a:buClrTx/>
+                        <a:buSzTx/>
+                        <a:buFontTx/>
+                        <a:buNone/>
+                        <a:tabLst/>
+                        <a:defRPr/>
+                      </a:pPr>
+                      <a:r>
+                        <a:rPr lang="en-US" sz="1500" kern="1200" dirty="0">
+                          <a:solidFill>
+                            <a:schemeClr val="tx1"/>
+                          </a:solidFill>
+                          <a:effectLst/>
+                          <a:latin typeface="+mn-lt"/>
+                          <a:ea typeface="+mn-ea"/>
+                          <a:cs typeface="+mn-cs"/>
+                        </a:rPr>
+                        <a:t>Healthy</a:t>
+                      </a:r>
+                    </a:p>
+                  </a:txBody>
+                  <a:tcPr/>
+                </a:tc>
+                <a:extLst>
+                  <a:ext uri="{0D108BD9-81ED-4DB2-BD59-A6C34878D82A}">
+                    <a16:rowId xmlns:a16="http://schemas.microsoft.com/office/drawing/2014/main" val="4095036216"/>
+                  </a:ext>
+                </a:extLst>
+              </a:tr>
+              <a:tr h="370840">
+                <a:tc>
+                  <a:txBody>
+                    <a:bodyPr/>
+                    <a:lstStyle/>
+                    <a:p>
+                      <a:r>
+                        <a:rPr lang="en-US" sz="1500" dirty="0"/>
+                        <a:t>F2</a:t>
+                      </a:r>
+                    </a:p>
+                  </a:txBody>
+                  <a:tcPr/>
+                </a:tc>
+                <a:tc>
+                  <a:txBody>
+                    <a:bodyPr/>
+                    <a:lstStyle/>
+                    <a:p>
+                      <a:r>
+                        <a:rPr lang="en-US" sz="1500" kern="1200" dirty="0">
+                          <a:solidFill>
+                            <a:schemeClr val="tx1"/>
+                          </a:solidFill>
+                          <a:effectLst/>
+                          <a:latin typeface="+mn-lt"/>
+                          <a:ea typeface="+mn-ea"/>
+                          <a:cs typeface="+mn-cs"/>
+                        </a:rPr>
+                        <a:t>Block inbound traffic on the target</a:t>
+                      </a:r>
+                    </a:p>
+                    <a:p>
+                      <a:r>
+                        <a:rPr lang="en-US" sz="1500" kern="1200" dirty="0">
+                          <a:solidFill>
+                            <a:schemeClr val="tx1"/>
+                          </a:solidFill>
+                          <a:effectLst/>
+                          <a:latin typeface="+mn-lt"/>
+                          <a:ea typeface="+mn-ea"/>
+                          <a:cs typeface="+mn-cs"/>
+                        </a:rPr>
+                        <a:t>agent data port</a:t>
+                      </a:r>
+                    </a:p>
+                  </a:txBody>
+                  <a:tcPr/>
+                </a:tc>
+                <a:tc>
+                  <a:txBody>
+                    <a:bodyPr/>
+                    <a:lstStyle/>
+                    <a:p>
+                      <a:pPr marL="0" marR="0" lvl="0" indent="0" algn="l" defTabSz="914400" rtl="0" eaLnBrk="1" fontAlgn="auto" latinLnBrk="0" hangingPunct="1">
+                        <a:lnSpc>
+                          <a:spcPct val="100000"/>
+                        </a:lnSpc>
+                        <a:spcBef>
+                          <a:spcPts val="0"/>
+                        </a:spcBef>
+                        <a:spcAft>
+                          <a:spcPts val="0"/>
+                        </a:spcAft>
+                        <a:buClrTx/>
+                        <a:buSzTx/>
+                        <a:buFontTx/>
+                        <a:buNone/>
+                        <a:tabLst/>
+                        <a:defRPr/>
+                      </a:pPr>
+                      <a:r>
+                        <a:rPr lang="en-US" sz="1500" kern="1200" dirty="0" err="1">
+                          <a:solidFill>
+                            <a:schemeClr val="tx1"/>
+                          </a:solidFill>
+                          <a:effectLst/>
+                          <a:latin typeface="+mn-lt"/>
+                          <a:ea typeface="+mn-ea"/>
+                          <a:cs typeface="+mn-cs"/>
+                        </a:rPr>
+                        <a:t>NodeIngressFailure</a:t>
+                      </a:r>
+                      <a:endParaRPr lang="en-US" sz="1500" kern="1200" dirty="0">
+                        <a:solidFill>
+                          <a:schemeClr val="tx1"/>
+                        </a:solidFill>
+                        <a:effectLst/>
+                        <a:latin typeface="+mn-lt"/>
+                        <a:ea typeface="+mn-ea"/>
+                        <a:cs typeface="+mn-cs"/>
+                      </a:endParaRPr>
+                    </a:p>
+                    <a:p>
+                      <a:endParaRPr lang="en-US" sz="1500" dirty="0"/>
+                    </a:p>
+                  </a:txBody>
+                  <a:tcPr/>
+                </a:tc>
+                <a:extLst>
+                  <a:ext uri="{0D108BD9-81ED-4DB2-BD59-A6C34878D82A}">
+                    <a16:rowId xmlns:a16="http://schemas.microsoft.com/office/drawing/2014/main" val="465000757"/>
+                  </a:ext>
+                </a:extLst>
+              </a:tr>
+              <a:tr h="370840">
+                <a:tc>
+                  <a:txBody>
+                    <a:bodyPr/>
+                    <a:lstStyle/>
+                    <a:p>
+                      <a:r>
+                        <a:rPr lang="en-US" sz="1500" dirty="0"/>
+                        <a:t>F3</a:t>
+                      </a:r>
+                    </a:p>
+                  </a:txBody>
+                  <a:tcPr/>
+                </a:tc>
+                <a:tc>
+                  <a:txBody>
+                    <a:bodyPr/>
+                    <a:lstStyle/>
+                    <a:p>
+                      <a:r>
+                        <a:rPr lang="en-US" sz="1500" kern="1200" dirty="0">
+                          <a:solidFill>
+                            <a:schemeClr val="tx1"/>
+                          </a:solidFill>
+                          <a:effectLst/>
+                          <a:latin typeface="+mn-lt"/>
+                          <a:ea typeface="+mn-ea"/>
+                          <a:cs typeface="+mn-cs"/>
+                        </a:rPr>
+                        <a:t>Block outbound traffic from the target</a:t>
+                      </a:r>
+                    </a:p>
+                    <a:p>
+                      <a:r>
+                        <a:rPr lang="en-US" sz="1500" kern="1200" dirty="0">
+                          <a:solidFill>
+                            <a:schemeClr val="tx1"/>
+                          </a:solidFill>
+                          <a:effectLst/>
+                          <a:latin typeface="+mn-lt"/>
+                          <a:ea typeface="+mn-ea"/>
+                          <a:cs typeface="+mn-cs"/>
+                        </a:rPr>
+                        <a:t>agent data port</a:t>
+                      </a:r>
+                    </a:p>
+                  </a:txBody>
+                  <a:tcPr/>
+                </a:tc>
+                <a:tc>
+                  <a:txBody>
+                    <a:bodyPr/>
+                    <a:lstStyle/>
+                    <a:p>
+                      <a:pPr marL="0" marR="0" lvl="0" indent="0" algn="l" defTabSz="914400" rtl="0" eaLnBrk="1" fontAlgn="auto" latinLnBrk="0" hangingPunct="1">
+                        <a:lnSpc>
+                          <a:spcPct val="100000"/>
+                        </a:lnSpc>
+                        <a:spcBef>
+                          <a:spcPts val="0"/>
+                        </a:spcBef>
+                        <a:spcAft>
+                          <a:spcPts val="0"/>
+                        </a:spcAft>
+                        <a:buClrTx/>
+                        <a:buSzTx/>
+                        <a:buFontTx/>
+                        <a:buNone/>
+                        <a:tabLst/>
+                        <a:defRPr/>
+                      </a:pPr>
+                      <a:r>
+                        <a:rPr lang="en-US" sz="1500" kern="1200" dirty="0" err="1">
+                          <a:solidFill>
+                            <a:schemeClr val="tx1"/>
+                          </a:solidFill>
+                          <a:effectLst/>
+                          <a:latin typeface="+mn-lt"/>
+                          <a:ea typeface="+mn-ea"/>
+                          <a:cs typeface="+mn-cs"/>
+                        </a:rPr>
+                        <a:t>NodeEgressFailure</a:t>
+                      </a:r>
+                      <a:endParaRPr lang="en-US" sz="1500" kern="1200" dirty="0">
+                        <a:solidFill>
+                          <a:schemeClr val="tx1"/>
+                        </a:solidFill>
+                        <a:effectLst/>
+                        <a:latin typeface="+mn-lt"/>
+                        <a:ea typeface="+mn-ea"/>
+                        <a:cs typeface="+mn-cs"/>
+                      </a:endParaRPr>
+                    </a:p>
+                    <a:p>
+                      <a:endParaRPr lang="en-US" sz="1500" dirty="0"/>
+                    </a:p>
+                  </a:txBody>
+                  <a:tcPr/>
+                </a:tc>
+                <a:extLst>
+                  <a:ext uri="{0D108BD9-81ED-4DB2-BD59-A6C34878D82A}">
+                    <a16:rowId xmlns:a16="http://schemas.microsoft.com/office/drawing/2014/main" val="3149341040"/>
+                  </a:ext>
+                </a:extLst>
+              </a:tr>
+              <a:tr h="370840">
+                <a:tc>
+                  <a:txBody>
+                    <a:bodyPr/>
+                    <a:lstStyle/>
+                    <a:p>
+                      <a:r>
+                        <a:rPr lang="en-US" sz="1500" dirty="0"/>
+                        <a:t>F4</a:t>
+                      </a:r>
+                    </a:p>
+                  </a:txBody>
+                  <a:tcPr/>
+                </a:tc>
+                <a:tc>
+                  <a:txBody>
+                    <a:bodyPr/>
+                    <a:lstStyle/>
+                    <a:p>
+                      <a:r>
+                        <a:rPr lang="en-US" sz="1500" kern="1200" dirty="0">
+                          <a:solidFill>
+                            <a:schemeClr val="tx1"/>
+                          </a:solidFill>
+                          <a:effectLst/>
+                          <a:latin typeface="+mn-lt"/>
+                          <a:ea typeface="+mn-ea"/>
+                          <a:cs typeface="+mn-cs"/>
+                        </a:rPr>
+                        <a:t>Kill Calico node pod and isolate the</a:t>
+                      </a:r>
+                    </a:p>
+                    <a:p>
+                      <a:r>
+                        <a:rPr lang="en-US" sz="1500" kern="1200" dirty="0">
+                          <a:solidFill>
+                            <a:schemeClr val="tx1"/>
+                          </a:solidFill>
+                          <a:effectLst/>
+                          <a:latin typeface="+mn-lt"/>
+                          <a:ea typeface="+mn-ea"/>
+                          <a:cs typeface="+mn-cs"/>
+                        </a:rPr>
+                        <a:t>agent data port</a:t>
+                      </a:r>
+                    </a:p>
+                  </a:txBody>
+                  <a:tcPr/>
+                </a:tc>
+                <a:tc>
+                  <a:txBody>
+                    <a:bodyPr/>
+                    <a:lstStyle/>
+                    <a:p>
+                      <a:pPr marL="0" marR="0" lvl="0" indent="0" algn="l" defTabSz="914400" rtl="0" eaLnBrk="1" fontAlgn="auto" latinLnBrk="0" hangingPunct="1">
+                        <a:lnSpc>
+                          <a:spcPct val="100000"/>
+                        </a:lnSpc>
+                        <a:spcBef>
+                          <a:spcPts val="0"/>
+                        </a:spcBef>
+                        <a:spcAft>
+                          <a:spcPts val="0"/>
+                        </a:spcAft>
+                        <a:buClrTx/>
+                        <a:buSzTx/>
+                        <a:buFontTx/>
+                        <a:buNone/>
+                        <a:tabLst/>
+                        <a:defRPr/>
+                      </a:pPr>
+                      <a:r>
+                        <a:rPr lang="en-US" sz="1500" kern="1200" dirty="0" err="1">
+                          <a:solidFill>
+                            <a:schemeClr val="tx1"/>
+                          </a:solidFill>
+                          <a:effectLst/>
+                          <a:latin typeface="+mn-lt"/>
+                          <a:ea typeface="+mn-ea"/>
+                          <a:cs typeface="+mn-cs"/>
+                        </a:rPr>
+                        <a:t>NodeIsolated</a:t>
+                      </a:r>
+                      <a:endParaRPr lang="en-US" sz="1500" kern="1200" dirty="0">
+                        <a:solidFill>
+                          <a:schemeClr val="tx1"/>
+                        </a:solidFill>
+                        <a:effectLst/>
+                        <a:latin typeface="+mn-lt"/>
+                        <a:ea typeface="+mn-ea"/>
+                        <a:cs typeface="+mn-cs"/>
+                      </a:endParaRPr>
+                    </a:p>
+                    <a:p>
+                      <a:endParaRPr lang="en-US" sz="1500" dirty="0"/>
+                    </a:p>
+                  </a:txBody>
+                  <a:tcPr/>
+                </a:tc>
+                <a:extLst>
+                  <a:ext uri="{0D108BD9-81ED-4DB2-BD59-A6C34878D82A}">
+                    <a16:rowId xmlns:a16="http://schemas.microsoft.com/office/drawing/2014/main" val="1035517472"/>
+                  </a:ext>
+                </a:extLst>
+              </a:tr>
+              <a:tr h="370840">
+                <a:tc>
+                  <a:txBody>
+                    <a:bodyPr/>
+                    <a:lstStyle/>
+                    <a:p>
+                      <a:r>
+                        <a:rPr lang="en-US" sz="1500" dirty="0"/>
+                        <a:t>F5</a:t>
+                      </a:r>
+                    </a:p>
+                  </a:txBody>
+                  <a:tcPr/>
+                </a:tc>
+                <a:tc>
+                  <a:txBody>
+                    <a:bodyPr/>
+                    <a:lstStyle/>
+                    <a:p>
+                      <a:r>
+                        <a:rPr lang="en-US" sz="1500" kern="1200" dirty="0">
+                          <a:solidFill>
+                            <a:schemeClr val="tx1"/>
+                          </a:solidFill>
+                          <a:effectLst/>
+                          <a:latin typeface="+mn-lt"/>
+                          <a:ea typeface="+mn-ea"/>
+                          <a:cs typeface="+mn-cs"/>
+                        </a:rPr>
+                        <a:t>Add 40 percent packet loss with </a:t>
+                      </a:r>
+                      <a:r>
+                        <a:rPr lang="en-US" sz="1500" kern="1200" dirty="0" err="1">
+                          <a:solidFill>
+                            <a:schemeClr val="tx1"/>
+                          </a:solidFill>
+                          <a:effectLst/>
+                          <a:latin typeface="+mn-lt"/>
+                          <a:ea typeface="+mn-ea"/>
+                          <a:cs typeface="+mn-cs"/>
+                        </a:rPr>
+                        <a:t>tc</a:t>
+                      </a:r>
+                      <a:endParaRPr lang="en-US" sz="1500" kern="1200" dirty="0">
+                        <a:solidFill>
+                          <a:schemeClr val="tx1"/>
+                        </a:solidFill>
+                        <a:effectLst/>
+                        <a:latin typeface="+mn-lt"/>
+                        <a:ea typeface="+mn-ea"/>
+                        <a:cs typeface="+mn-cs"/>
+                      </a:endParaRPr>
+                    </a:p>
+                    <a:p>
+                      <a:r>
+                        <a:rPr lang="en-US" sz="1500" kern="1200" dirty="0" err="1">
+                          <a:solidFill>
+                            <a:schemeClr val="tx1"/>
+                          </a:solidFill>
+                          <a:effectLst/>
+                          <a:latin typeface="+mn-lt"/>
+                          <a:ea typeface="+mn-ea"/>
+                          <a:cs typeface="+mn-cs"/>
+                        </a:rPr>
+                        <a:t>netem</a:t>
+                      </a:r>
+                      <a:endParaRPr lang="en-US" sz="1500" kern="1200" dirty="0">
+                        <a:solidFill>
+                          <a:schemeClr val="tx1"/>
+                        </a:solidFill>
+                        <a:effectLst/>
+                        <a:latin typeface="+mn-lt"/>
+                        <a:ea typeface="+mn-ea"/>
+                        <a:cs typeface="+mn-cs"/>
+                      </a:endParaRPr>
+                    </a:p>
+                  </a:txBody>
+                  <a:tcPr/>
+                </a:tc>
+                <a:tc>
+                  <a:txBody>
+                    <a:bodyPr/>
+                    <a:lstStyle/>
+                    <a:p>
+                      <a:r>
+                        <a:rPr lang="en-US" sz="1500" kern="1200" dirty="0">
+                          <a:solidFill>
+                            <a:schemeClr val="tx1"/>
+                          </a:solidFill>
+                          <a:effectLst/>
+                          <a:latin typeface="+mn-lt"/>
+                          <a:ea typeface="+mn-ea"/>
+                          <a:cs typeface="+mn-cs"/>
+                        </a:rPr>
+                        <a:t>Degraded or degraded evidence in</a:t>
+                      </a:r>
+                    </a:p>
+                    <a:p>
+                      <a:r>
+                        <a:rPr lang="en-US" sz="1500" kern="1200" dirty="0">
+                          <a:solidFill>
+                            <a:schemeClr val="tx1"/>
+                          </a:solidFill>
+                          <a:effectLst/>
+                          <a:latin typeface="+mn-lt"/>
+                          <a:ea typeface="+mn-ea"/>
+                          <a:cs typeface="+mn-cs"/>
+                        </a:rPr>
+                        <a:t>metrics</a:t>
+                      </a:r>
+                    </a:p>
+                  </a:txBody>
+                  <a:tcPr/>
+                </a:tc>
+                <a:extLst>
+                  <a:ext uri="{0D108BD9-81ED-4DB2-BD59-A6C34878D82A}">
+                    <a16:rowId xmlns:a16="http://schemas.microsoft.com/office/drawing/2014/main" val="3703048224"/>
+                  </a:ext>
+                </a:extLst>
+              </a:tr>
+              <a:tr h="370840">
+                <a:tc>
+                  <a:txBody>
+                    <a:bodyPr/>
+                    <a:lstStyle/>
+                    <a:p>
+                      <a:r>
+                        <a:rPr lang="en-US" sz="1500" dirty="0"/>
+                        <a:t>F6</a:t>
+                      </a:r>
+                    </a:p>
+                  </a:txBody>
+                  <a:tcPr/>
+                </a:tc>
+                <a:tc>
+                  <a:txBody>
+                    <a:bodyPr/>
+                    <a:lstStyle/>
+                    <a:p>
+                      <a:pPr marL="0" marR="0" lvl="0" indent="0" algn="l" defTabSz="914400" rtl="0" eaLnBrk="1" fontAlgn="auto" latinLnBrk="0" hangingPunct="1">
+                        <a:lnSpc>
+                          <a:spcPct val="100000"/>
+                        </a:lnSpc>
+                        <a:spcBef>
+                          <a:spcPts val="0"/>
+                        </a:spcBef>
+                        <a:spcAft>
+                          <a:spcPts val="0"/>
+                        </a:spcAft>
+                        <a:buClrTx/>
+                        <a:buSzTx/>
+                        <a:buFontTx/>
+                        <a:buNone/>
+                        <a:tabLst/>
+                        <a:defRPr/>
+                      </a:pPr>
+                      <a:r>
+                        <a:rPr lang="en-US" sz="1500" kern="1200" dirty="0">
+                          <a:solidFill>
+                            <a:schemeClr val="tx1"/>
+                          </a:solidFill>
+                          <a:effectLst/>
+                          <a:latin typeface="+mn-lt"/>
+                          <a:ea typeface="+mn-ea"/>
+                          <a:cs typeface="+mn-cs"/>
+                        </a:rPr>
+                        <a:t>Apply deny-all </a:t>
+                      </a:r>
+                      <a:r>
+                        <a:rPr lang="en-US" sz="1500" kern="1200" dirty="0" err="1">
+                          <a:solidFill>
+                            <a:schemeClr val="tx1"/>
+                          </a:solidFill>
+                          <a:effectLst/>
+                          <a:latin typeface="+mn-lt"/>
+                          <a:ea typeface="+mn-ea"/>
+                          <a:cs typeface="+mn-cs"/>
+                        </a:rPr>
+                        <a:t>NetworkPolicy</a:t>
+                      </a:r>
+                      <a:r>
+                        <a:rPr lang="en-US" sz="1500" kern="1200" dirty="0">
+                          <a:solidFill>
+                            <a:schemeClr val="tx1"/>
+                          </a:solidFill>
+                          <a:effectLst/>
+                          <a:latin typeface="+mn-lt"/>
+                          <a:ea typeface="+mn-ea"/>
+                          <a:cs typeface="+mn-cs"/>
+                        </a:rPr>
+                        <a:t> </a:t>
+                      </a:r>
+                    </a:p>
+                  </a:txBody>
+                  <a:tcPr/>
+                </a:tc>
+                <a:tc>
+                  <a:txBody>
+                    <a:bodyPr/>
+                    <a:lstStyle/>
+                    <a:p>
+                      <a:r>
+                        <a:rPr lang="en-US" sz="1500" kern="1200" dirty="0" err="1">
+                          <a:solidFill>
+                            <a:schemeClr val="tx1"/>
+                          </a:solidFill>
+                          <a:effectLst/>
+                          <a:latin typeface="+mn-lt"/>
+                          <a:ea typeface="+mn-ea"/>
+                          <a:cs typeface="+mn-cs"/>
+                        </a:rPr>
+                        <a:t>ClusterPartition</a:t>
+                      </a:r>
+                      <a:r>
+                        <a:rPr lang="en-US" sz="1500" kern="1200" dirty="0">
+                          <a:solidFill>
+                            <a:schemeClr val="tx1"/>
+                          </a:solidFill>
+                          <a:effectLst/>
+                          <a:latin typeface="+mn-lt"/>
+                          <a:ea typeface="+mn-ea"/>
+                          <a:cs typeface="+mn-cs"/>
+                        </a:rPr>
+                        <a:t> or</a:t>
+                      </a:r>
+                    </a:p>
+                    <a:p>
+                      <a:r>
+                        <a:rPr lang="en-US" sz="1500" kern="1200" dirty="0" err="1">
+                          <a:solidFill>
+                            <a:schemeClr val="tx1"/>
+                          </a:solidFill>
+                          <a:effectLst/>
+                          <a:latin typeface="+mn-lt"/>
+                          <a:ea typeface="+mn-ea"/>
+                          <a:cs typeface="+mn-cs"/>
+                        </a:rPr>
+                        <a:t>PolicyScopedFailure</a:t>
+                      </a:r>
+                      <a:r>
+                        <a:rPr lang="en-US" sz="1500" kern="1200" dirty="0">
+                          <a:solidFill>
+                            <a:schemeClr val="tx1"/>
+                          </a:solidFill>
+                          <a:effectLst/>
+                          <a:latin typeface="+mn-lt"/>
+                          <a:ea typeface="+mn-ea"/>
+                          <a:cs typeface="+mn-cs"/>
+                        </a:rPr>
+                        <a:t>, depending on</a:t>
+                      </a:r>
+                    </a:p>
+                    <a:p>
+                      <a:r>
+                        <a:rPr lang="en-US" sz="1500" kern="1200" dirty="0">
+                          <a:solidFill>
+                            <a:schemeClr val="tx1"/>
+                          </a:solidFill>
+                          <a:effectLst/>
+                          <a:latin typeface="+mn-lt"/>
+                          <a:ea typeface="+mn-ea"/>
+                          <a:cs typeface="+mn-cs"/>
+                        </a:rPr>
+                        <a:t>observed error pattern</a:t>
+                      </a:r>
+                    </a:p>
+                  </a:txBody>
+                  <a:tcPr/>
+                </a:tc>
+                <a:extLst>
+                  <a:ext uri="{0D108BD9-81ED-4DB2-BD59-A6C34878D82A}">
+                    <a16:rowId xmlns:a16="http://schemas.microsoft.com/office/drawing/2014/main" val="2215161180"/>
+                  </a:ext>
+                </a:extLst>
+              </a:tr>
+            </a:tbl>
+          </a:graphicData>
+        </a:graphic>
+      </p:graphicFrame>
     </p:spTree>
     <p:extLst>
       <p:ext uri="{BB962C8B-B14F-4D97-AF65-F5344CB8AC3E}">
@@ -20113,6 +21038,107 @@
   <p:cSld>
     <p:spTree>
       <p:nvGrpSpPr>
+        <p:cNvPr id="1" name="">
+          <a:extLst>
+            <a:ext uri="{FF2B5EF4-FFF2-40B4-BE49-F238E27FC236}">
+              <a16:creationId xmlns:a16="http://schemas.microsoft.com/office/drawing/2014/main" id="{E0CA8F03-8098-96D4-9B20-F49ABDE1C01D}"/>
+            </a:ext>
+          </a:extLst>
+        </p:cNvPr>
+        <p:cNvGrpSpPr/>
+        <p:nvPr/>
+      </p:nvGrpSpPr>
+      <p:grpSpPr>
+        <a:xfrm>
+          <a:off x="0" y="0"/>
+          <a:ext cx="0" cy="0"/>
+          <a:chOff x="0" y="0"/>
+          <a:chExt cx="0" cy="0"/>
+        </a:xfrm>
+      </p:grpSpPr>
+      <p:sp>
+        <p:nvSpPr>
+          <p:cNvPr id="2" name="Title 1">
+            <a:extLst>
+              <a:ext uri="{FF2B5EF4-FFF2-40B4-BE49-F238E27FC236}">
+                <a16:creationId xmlns:a16="http://schemas.microsoft.com/office/drawing/2014/main" id="{18D15A82-BA4D-164A-AF4E-9061EB65A3BE}"/>
+              </a:ext>
+            </a:extLst>
+          </p:cNvPr>
+          <p:cNvSpPr>
+            <a:spLocks noGrp="1"/>
+          </p:cNvSpPr>
+          <p:nvPr>
+            <p:ph type="title"/>
+          </p:nvPr>
+        </p:nvSpPr>
+        <p:spPr/>
+        <p:txBody>
+          <a:bodyPr/>
+          <a:lstStyle/>
+          <a:p>
+            <a:r>
+              <a:rPr lang="en-US" dirty="0"/>
+              <a:t>Results of Evaluations</a:t>
+            </a:r>
+            <a:endParaRPr lang="en-IN" dirty="0"/>
+          </a:p>
+        </p:txBody>
+      </p:sp>
+      <p:pic>
+        <p:nvPicPr>
+          <p:cNvPr id="5" name="Picture 4" descr="A table with numbers and text&#10;&#10;AI-generated content may be incorrect.">
+            <a:extLst>
+              <a:ext uri="{FF2B5EF4-FFF2-40B4-BE49-F238E27FC236}">
+                <a16:creationId xmlns:a16="http://schemas.microsoft.com/office/drawing/2014/main" id="{2573CA4D-E960-EB0B-D2A2-5D15E252F375}"/>
+              </a:ext>
+            </a:extLst>
+          </p:cNvPr>
+          <p:cNvPicPr>
+            <a:picLocks noChangeAspect="1"/>
+          </p:cNvPicPr>
+          <p:nvPr/>
+        </p:nvPicPr>
+        <p:blipFill>
+          <a:blip r:embed="rId2">
+            <a:extLst>
+              <a:ext uri="{28A0092B-C50C-407E-A947-70E740481C1C}">
+                <a14:useLocalDpi xmlns:a14="http://schemas.microsoft.com/office/drawing/2010/main" val="0"/>
+              </a:ext>
+            </a:extLst>
+          </a:blip>
+          <a:stretch>
+            <a:fillRect/>
+          </a:stretch>
+        </p:blipFill>
+        <p:spPr>
+          <a:xfrm>
+            <a:off x="992726" y="2139505"/>
+            <a:ext cx="10206547" cy="2578989"/>
+          </a:xfrm>
+          <a:prstGeom prst="rect">
+            <a:avLst/>
+          </a:prstGeom>
+        </p:spPr>
+      </p:pic>
+    </p:spTree>
+    <p:extLst>
+      <p:ext uri="{BB962C8B-B14F-4D97-AF65-F5344CB8AC3E}">
+        <p14:creationId xmlns:p14="http://schemas.microsoft.com/office/powerpoint/2010/main" val="700174877"/>
+      </p:ext>
+    </p:extLst>
+  </p:cSld>
+  <p:clrMapOvr>
+    <a:masterClrMapping/>
+  </p:clrMapOvr>
+</p:sld>
+</file>
+
+<file path=ppt/slides/slide14.xml><?xml version="1.0" encoding="utf-8"?>
+<p:sld xmlns:a="http://schemas.openxmlformats.org/drawingml/2006/main" xmlns:r="http://schemas.openxmlformats.org/officeDocument/2006/relationships" xmlns:p="http://schemas.openxmlformats.org/presentationml/2006/main">
+  <p:cSld>
+    <p:spTree>
+      <p:nvGrpSpPr>
         <p:cNvPr id="1" name=""/>
         <p:cNvGrpSpPr/>
         <p:nvPr/>
@@ -20150,31 +21176,6 @@
               <a:rPr lang="en-US" dirty="0"/>
               <a:t>Thank You</a:t>
             </a:r>
-            <a:endParaRPr lang="en-IN" dirty="0"/>
-          </a:p>
-        </p:txBody>
-      </p:sp>
-      <p:sp>
-        <p:nvSpPr>
-          <p:cNvPr id="6" name="Content Placeholder 5">
-            <a:extLst>
-              <a:ext uri="{FF2B5EF4-FFF2-40B4-BE49-F238E27FC236}">
-                <a16:creationId xmlns:a16="http://schemas.microsoft.com/office/drawing/2014/main" id="{68BDBB92-3DF5-4DE6-EE9A-BDF62F4F3385}"/>
-              </a:ext>
-            </a:extLst>
-          </p:cNvPr>
-          <p:cNvSpPr>
-            <a:spLocks noGrp="1"/>
-          </p:cNvSpPr>
-          <p:nvPr>
-            <p:ph sz="quarter" idx="13"/>
-          </p:nvPr>
-        </p:nvSpPr>
-        <p:spPr/>
-        <p:txBody>
-          <a:bodyPr/>
-          <a:lstStyle/>
-          <a:p>
             <a:endParaRPr lang="en-IN" dirty="0"/>
           </a:p>
         </p:txBody>
@@ -22048,6 +23049,26 @@
 </file>
 
 <file path=customXml/item1.xml><?xml version="1.0" encoding="utf-8"?>
+<p:properties xmlns:p="http://schemas.microsoft.com/office/2006/metadata/properties" xmlns:xsi="http://www.w3.org/2001/XMLSchema-instance" xmlns:pc="http://schemas.microsoft.com/office/infopath/2007/PartnerControls">
+  <documentManagement>
+    <_ip_UnifiedCompliancePolicyUIAction xmlns="http://schemas.microsoft.com/sharepoint/v3" xsi:nil="true"/>
+    <Image xmlns="71af3243-3dd4-4a8d-8c0d-dd76da1f02a5">
+      <Url xsi:nil="true"/>
+      <Description xsi:nil="true"/>
+    </Image>
+    <Status xmlns="71af3243-3dd4-4a8d-8c0d-dd76da1f02a5">Not started</Status>
+    <Background xmlns="71af3243-3dd4-4a8d-8c0d-dd76da1f02a5">false</Background>
+    <_ip_UnifiedCompliancePolicyProperties xmlns="http://schemas.microsoft.com/sharepoint/v3" xsi:nil="true"/>
+    <ImageTagsTaxHTField xmlns="71af3243-3dd4-4a8d-8c0d-dd76da1f02a5">
+      <Terms xmlns="http://schemas.microsoft.com/office/infopath/2007/PartnerControls"/>
+    </ImageTagsTaxHTField>
+    <TaxCatchAll xmlns="230e9df3-be65-4c73-a93b-d1236ebd677e" xsi:nil="true"/>
+    <MediaServiceKeyPoints xmlns="71af3243-3dd4-4a8d-8c0d-dd76da1f02a5" xsi:nil="true"/>
+  </documentManagement>
+</p:properties>
+</file>
+
+<file path=customXml/item2.xml><?xml version="1.0" encoding="utf-8"?>
 <ct:contentTypeSchema xmlns:ct="http://schemas.microsoft.com/office/2006/metadata/contentType" xmlns:ma="http://schemas.microsoft.com/office/2006/metadata/properties/metaAttributes" ct:_="" ma:_="" ma:contentTypeName="Document" ma:contentTypeID="0x01010079F111ED35F8CC479449609E8A0923A6" ma:contentTypeVersion="30" ma:contentTypeDescription="Create a new document." ma:contentTypeScope="" ma:versionID="cec0622158e8f13124e9e8fd4de31bd1">
   <xsd:schema xmlns:xsd="http://www.w3.org/2001/XMLSchema" xmlns:xs="http://www.w3.org/2001/XMLSchema" xmlns:p="http://schemas.microsoft.com/office/2006/metadata/properties" xmlns:ns1="http://schemas.microsoft.com/sharepoint/v3" xmlns:ns2="71af3243-3dd4-4a8d-8c0d-dd76da1f02a5" xmlns:ns3="16c05727-aa75-4e4a-9b5f-8a80a1165891" xmlns:ns4="230e9df3-be65-4c73-a93b-d1236ebd677e" targetNamespace="http://schemas.microsoft.com/office/2006/metadata/properties" ma:root="true" ma:fieldsID="3b52f30ab005d15df08657af532e6e38" ns1:_="" ns2:_="" ns3:_="" ns4:_="">
     <xsd:import namespace="http://schemas.microsoft.com/sharepoint/v3"/>
@@ -22365,26 +23386,6 @@
 </ct:contentTypeSchema>
 </file>
 
-<file path=customXml/item2.xml><?xml version="1.0" encoding="utf-8"?>
-<p:properties xmlns:p="http://schemas.microsoft.com/office/2006/metadata/properties" xmlns:xsi="http://www.w3.org/2001/XMLSchema-instance" xmlns:pc="http://schemas.microsoft.com/office/infopath/2007/PartnerControls">
-  <documentManagement>
-    <_ip_UnifiedCompliancePolicyUIAction xmlns="http://schemas.microsoft.com/sharepoint/v3" xsi:nil="true"/>
-    <Image xmlns="71af3243-3dd4-4a8d-8c0d-dd76da1f02a5">
-      <Url xsi:nil="true"/>
-      <Description xsi:nil="true"/>
-    </Image>
-    <Status xmlns="71af3243-3dd4-4a8d-8c0d-dd76da1f02a5">Not started</Status>
-    <Background xmlns="71af3243-3dd4-4a8d-8c0d-dd76da1f02a5">false</Background>
-    <_ip_UnifiedCompliancePolicyProperties xmlns="http://schemas.microsoft.com/sharepoint/v3" xsi:nil="true"/>
-    <ImageTagsTaxHTField xmlns="71af3243-3dd4-4a8d-8c0d-dd76da1f02a5">
-      <Terms xmlns="http://schemas.microsoft.com/office/infopath/2007/PartnerControls"/>
-    </ImageTagsTaxHTField>
-    <TaxCatchAll xmlns="230e9df3-be65-4c73-a93b-d1236ebd677e" xsi:nil="true"/>
-    <MediaServiceKeyPoints xmlns="71af3243-3dd4-4a8d-8c0d-dd76da1f02a5" xsi:nil="true"/>
-  </documentManagement>
-</p:properties>
-</file>
-
 <file path=customXml/item3.xml><?xml version="1.0" encoding="utf-8"?>
 <?mso-contentType ?>
 <FormTemplates xmlns="http://schemas.microsoft.com/sharepoint/v3/contenttype/forms">
@@ -22395,6 +23396,25 @@
 </file>
 
 <file path=customXml/itemProps1.xml><?xml version="1.0" encoding="utf-8"?>
+<ds:datastoreItem xmlns:ds="http://schemas.openxmlformats.org/officeDocument/2006/customXml" ds:itemID="{52185BFC-6E97-4C88-9034-F2A7ED1C005E}">
+  <ds:schemaRefs>
+    <ds:schemaRef ds:uri="http://purl.org/dc/terms/"/>
+    <ds:schemaRef ds:uri="http://purl.org/dc/elements/1.1/"/>
+    <ds:schemaRef ds:uri="http://schemas.microsoft.com/office/2006/documentManagement/types"/>
+    <ds:schemaRef ds:uri="http://www.w3.org/XML/1998/namespace"/>
+    <ds:schemaRef ds:uri="71af3243-3dd4-4a8d-8c0d-dd76da1f02a5"/>
+    <ds:schemaRef ds:uri="230e9df3-be65-4c73-a93b-d1236ebd677e"/>
+    <ds:schemaRef ds:uri="16c05727-aa75-4e4a-9b5f-8a80a1165891"/>
+    <ds:schemaRef ds:uri="http://schemas.openxmlformats.org/package/2006/metadata/core-properties"/>
+    <ds:schemaRef ds:uri="http://schemas.microsoft.com/office/2006/metadata/properties"/>
+    <ds:schemaRef ds:uri="http://schemas.microsoft.com/office/infopath/2007/PartnerControls"/>
+    <ds:schemaRef ds:uri="http://schemas.microsoft.com/sharepoint/v3"/>
+    <ds:schemaRef ds:uri="http://purl.org/dc/dcmitype/"/>
+  </ds:schemaRefs>
+</ds:datastoreItem>
+</file>
+
+<file path=customXml/itemProps2.xml><?xml version="1.0" encoding="utf-8"?>
 <ds:datastoreItem xmlns:ds="http://schemas.openxmlformats.org/officeDocument/2006/customXml" ds:itemID="{52BAF2CE-2C32-498E-B467-6C60C376794B}">
   <ds:schemaRefs>
     <ds:schemaRef ds:uri="http://schemas.microsoft.com/office/2006/metadata/contentType"/>
@@ -22415,25 +23435,6 @@
 </ds:datastoreItem>
 </file>
 
-<file path=customXml/itemProps2.xml><?xml version="1.0" encoding="utf-8"?>
-<ds:datastoreItem xmlns:ds="http://schemas.openxmlformats.org/officeDocument/2006/customXml" ds:itemID="{52185BFC-6E97-4C88-9034-F2A7ED1C005E}">
-  <ds:schemaRefs>
-    <ds:schemaRef ds:uri="http://purl.org/dc/terms/"/>
-    <ds:schemaRef ds:uri="http://purl.org/dc/elements/1.1/"/>
-    <ds:schemaRef ds:uri="http://schemas.microsoft.com/office/2006/documentManagement/types"/>
-    <ds:schemaRef ds:uri="http://www.w3.org/XML/1998/namespace"/>
-    <ds:schemaRef ds:uri="71af3243-3dd4-4a8d-8c0d-dd76da1f02a5"/>
-    <ds:schemaRef ds:uri="230e9df3-be65-4c73-a93b-d1236ebd677e"/>
-    <ds:schemaRef ds:uri="16c05727-aa75-4e4a-9b5f-8a80a1165891"/>
-    <ds:schemaRef ds:uri="http://schemas.openxmlformats.org/package/2006/metadata/core-properties"/>
-    <ds:schemaRef ds:uri="http://schemas.microsoft.com/office/2006/metadata/properties"/>
-    <ds:schemaRef ds:uri="http://schemas.microsoft.com/office/infopath/2007/PartnerControls"/>
-    <ds:schemaRef ds:uri="http://schemas.microsoft.com/sharepoint/v3"/>
-    <ds:schemaRef ds:uri="http://purl.org/dc/dcmitype/"/>
-  </ds:schemaRefs>
-</ds:datastoreItem>
-</file>
-
 <file path=customXml/itemProps3.xml><?xml version="1.0" encoding="utf-8"?>
 <ds:datastoreItem xmlns:ds="http://schemas.openxmlformats.org/officeDocument/2006/customXml" ds:itemID="{881A4212-02C6-475D-B332-DC5017D04534}">
   <ds:schemaRefs>

</xml_diff>